<commit_message>
Fira Sans Schrift in allen Praesentationen (wie Vorlage)
</commit_message>
<xml_diff>
--- a/praesentationen-pptx/Elevator42_Modul9_Slides.pptx
+++ b/praesentationen-pptx/Elevator42_Modul9_Slides.pptx
@@ -1507,13 +1507,13 @@
               <a:buNone/>
             </a:pPr>
             <a:r>
-              <a:rPr lang="en-US" sz="3000" b="1" dirty="0">
+              <a:rPr lang="en-US" sz="3000" dirty="0">
                 <a:solidFill>
                   <a:srgbClr val="FFFFFF"/>
                 </a:solidFill>
-                <a:latin typeface="Georgia" pitchFamily="34" charset="0"/>
-                <a:ea typeface="Georgia" pitchFamily="34" charset="-122"/>
-                <a:cs typeface="Georgia" pitchFamily="34" charset="-120"/>
+                <a:latin typeface="Fira Sans ExtraBold" pitchFamily="34" charset="0"/>
+                <a:ea typeface="Fira Sans ExtraBold" pitchFamily="34" charset="-122"/>
+                <a:cs typeface="Fira Sans ExtraBold" pitchFamily="34" charset="-120"/>
               </a:rPr>
               <a:t>Mehr</a:t>
             </a:r>
@@ -1527,13 +1527,13 @@
               <a:buNone/>
             </a:pPr>
             <a:r>
-              <a:rPr lang="en-US" sz="3000" b="1" dirty="0">
+              <a:rPr lang="en-US" sz="3000" dirty="0">
                 <a:solidFill>
                   <a:srgbClr val="FFFFFF"/>
                 </a:solidFill>
-                <a:latin typeface="Georgia" pitchFamily="34" charset="0"/>
-                <a:ea typeface="Georgia" pitchFamily="34" charset="-122"/>
-                <a:cs typeface="Georgia" pitchFamily="34" charset="-120"/>
+                <a:latin typeface="Fira Sans ExtraBold" pitchFamily="34" charset="0"/>
+                <a:ea typeface="Fira Sans ExtraBold" pitchFamily="34" charset="-122"/>
+                <a:cs typeface="Fira Sans ExtraBold" pitchFamily="34" charset="-120"/>
               </a:rPr>
               <a:t>Privatpatienten</a:t>
             </a:r>
@@ -1547,13 +1547,13 @@
               <a:buNone/>
             </a:pPr>
             <a:r>
-              <a:rPr lang="en-US" sz="3000" b="1" dirty="0">
+              <a:rPr lang="en-US" sz="3000" dirty="0">
                 <a:solidFill>
                   <a:srgbClr val="FFFFFF"/>
                 </a:solidFill>
-                <a:latin typeface="Georgia" pitchFamily="34" charset="0"/>
-                <a:ea typeface="Georgia" pitchFamily="34" charset="-122"/>
-                <a:cs typeface="Georgia" pitchFamily="34" charset="-120"/>
+                <a:latin typeface="Fira Sans ExtraBold" pitchFamily="34" charset="0"/>
+                <a:ea typeface="Fira Sans ExtraBold" pitchFamily="34" charset="-122"/>
+                <a:cs typeface="Fira Sans ExtraBold" pitchFamily="34" charset="-120"/>
               </a:rPr>
               <a:t>&amp; Selbstzahler</a:t>
             </a:r>
@@ -1567,13 +1567,13 @@
               <a:buNone/>
             </a:pPr>
             <a:r>
-              <a:rPr lang="en-US" sz="3000" b="1" dirty="0">
+              <a:rPr lang="en-US" sz="3000" dirty="0">
                 <a:solidFill>
                   <a:srgbClr val="FFFFFF"/>
                 </a:solidFill>
-                <a:latin typeface="Georgia" pitchFamily="34" charset="0"/>
-                <a:ea typeface="Georgia" pitchFamily="34" charset="-122"/>
-                <a:cs typeface="Georgia" pitchFamily="34" charset="-120"/>
+                <a:latin typeface="Fira Sans ExtraBold" pitchFamily="34" charset="0"/>
+                <a:ea typeface="Fira Sans ExtraBold" pitchFamily="34" charset="-122"/>
+                <a:cs typeface="Fira Sans ExtraBold" pitchFamily="34" charset="-120"/>
               </a:rPr>
               <a:t>gewinnen</a:t>
             </a:r>
@@ -1610,9 +1610,9 @@
                 <a:solidFill>
                   <a:srgbClr val="D6DCE5"/>
                 </a:solidFill>
-                <a:latin typeface="Calibri" pitchFamily="34" charset="0"/>
-                <a:ea typeface="Calibri" pitchFamily="34" charset="-122"/>
-                <a:cs typeface="Calibri" pitchFamily="34" charset="-120"/>
+                <a:latin typeface="Fira Sans" pitchFamily="34" charset="0"/>
+                <a:ea typeface="Fira Sans" pitchFamily="34" charset="-122"/>
+                <a:cs typeface="Fira Sans" pitchFamily="34" charset="-120"/>
               </a:rPr>
               <a:t>Die wirtschaftliche</a:t>
             </a:r>
@@ -1627,9 +1627,9 @@
                 <a:solidFill>
                   <a:srgbClr val="D6DCE5"/>
                 </a:solidFill>
-                <a:latin typeface="Calibri" pitchFamily="34" charset="0"/>
-                <a:ea typeface="Calibri" pitchFamily="34" charset="-122"/>
-                <a:cs typeface="Calibri" pitchFamily="34" charset="-120"/>
+                <a:latin typeface="Fira Sans" pitchFamily="34" charset="0"/>
+                <a:ea typeface="Fira Sans" pitchFamily="34" charset="-122"/>
+                <a:cs typeface="Fira Sans" pitchFamily="34" charset="-120"/>
               </a:rPr>
               <a:t>Wachstumsstrategie fuer</a:t>
             </a:r>
@@ -1644,9 +1644,9 @@
                 <a:solidFill>
                   <a:srgbClr val="D6DCE5"/>
                 </a:solidFill>
-                <a:latin typeface="Calibri" pitchFamily="34" charset="0"/>
-                <a:ea typeface="Calibri" pitchFamily="34" charset="-122"/>
-                <a:cs typeface="Calibri" pitchFamily="34" charset="-120"/>
+                <a:latin typeface="Fira Sans" pitchFamily="34" charset="0"/>
+                <a:ea typeface="Fira Sans" pitchFamily="34" charset="-122"/>
+                <a:cs typeface="Fira Sans" pitchFamily="34" charset="-120"/>
               </a:rPr>
               <a:t>moderne Praxen</a:t>
             </a:r>
@@ -1749,9 +1749,9 @@
                 <a:solidFill>
                   <a:srgbClr val="FFFFFF"/>
                 </a:solidFill>
-                <a:latin typeface="Calibri" pitchFamily="34" charset="0"/>
-                <a:ea typeface="Calibri" pitchFamily="34" charset="-122"/>
-                <a:cs typeface="Calibri" pitchFamily="34" charset="-120"/>
+                <a:latin typeface="Fira Sans" pitchFamily="34" charset="0"/>
+                <a:ea typeface="Fira Sans" pitchFamily="34" charset="-122"/>
+                <a:cs typeface="Fira Sans" pitchFamily="34" charset="-120"/>
               </a:rPr>
               <a:t>▶ 0:24</a:t>
             </a:r>
@@ -1863,9 +1863,9 @@
                 <a:solidFill>
                   <a:srgbClr val="6B7280"/>
                 </a:solidFill>
-                <a:latin typeface="Calibri" pitchFamily="34" charset="0"/>
-                <a:ea typeface="Calibri" pitchFamily="34" charset="-122"/>
-                <a:cs typeface="Calibri" pitchFamily="34" charset="-120"/>
+                <a:latin typeface="Fira Sans" pitchFamily="34" charset="0"/>
+                <a:ea typeface="Fira Sans" pitchFamily="34" charset="-122"/>
+                <a:cs typeface="Fira Sans" pitchFamily="34" charset="-120"/>
               </a:rPr>
               <a:t>MODUL</a:t>
             </a:r>
@@ -1902,9 +1902,9 @@
                 <a:solidFill>
                   <a:srgbClr val="893163"/>
                 </a:solidFill>
-                <a:latin typeface="Georgia" pitchFamily="34" charset="0"/>
-                <a:ea typeface="Georgia" pitchFamily="34" charset="-122"/>
-                <a:cs typeface="Georgia" pitchFamily="34" charset="-120"/>
+                <a:latin typeface="Fira Sans SemiBold" pitchFamily="34" charset="0"/>
+                <a:ea typeface="Fira Sans SemiBold" pitchFamily="34" charset="-122"/>
+                <a:cs typeface="Fira Sans SemiBold" pitchFamily="34" charset="-120"/>
               </a:rPr>
               <a:t>#09</a:t>
             </a:r>
@@ -1941,9 +1941,9 @@
                 <a:solidFill>
                   <a:srgbClr val="3D3D5C"/>
                 </a:solidFill>
-                <a:latin typeface="Calibri" pitchFamily="34" charset="0"/>
-                <a:ea typeface="Calibri" pitchFamily="34" charset="-122"/>
-                <a:cs typeface="Calibri" pitchFamily="34" charset="-120"/>
+                <a:latin typeface="Fira Sans" pitchFamily="34" charset="0"/>
+                <a:ea typeface="Fira Sans" pitchFamily="34" charset="-122"/>
+                <a:cs typeface="Fira Sans" pitchFamily="34" charset="-120"/>
               </a:rPr>
               <a:t>Sichtbarkeit und Empfehlungen</a:t>
             </a:r>
@@ -1980,9 +1980,9 @@
                 <a:solidFill>
                   <a:srgbClr val="1F4E79"/>
                 </a:solidFill>
-                <a:latin typeface="Georgia" pitchFamily="34" charset="0"/>
-                <a:ea typeface="Georgia" pitchFamily="34" charset="-122"/>
-                <a:cs typeface="Georgia" pitchFamily="34" charset="-120"/>
+                <a:latin typeface="Fira Sans SemiBold" pitchFamily="34" charset="0"/>
+                <a:ea typeface="Fira Sans SemiBold" pitchFamily="34" charset="-122"/>
+                <a:cs typeface="Fira Sans SemiBold" pitchFamily="34" charset="-120"/>
               </a:rPr>
               <a:t>Marketing &amp; Wachstum</a:t>
             </a:r>
@@ -2019,9 +2019,9 @@
                 <a:solidFill>
                   <a:srgbClr val="3D3D5C"/>
                 </a:solidFill>
-                <a:latin typeface="Calibri" pitchFamily="34" charset="0"/>
-                <a:ea typeface="Calibri" pitchFamily="34" charset="-122"/>
-                <a:cs typeface="Calibri" pitchFamily="34" charset="-120"/>
+                <a:latin typeface="Fira Sans" pitchFamily="34" charset="0"/>
+                <a:ea typeface="Fira Sans" pitchFamily="34" charset="-122"/>
+                <a:cs typeface="Fira Sans" pitchFamily="34" charset="-120"/>
               </a:rPr>
               <a:t>Sichtbarkeit und Empfehlungen</a:t>
             </a:r>
@@ -2078,9 +2078,9 @@
                 <a:solidFill>
                   <a:srgbClr val="893163"/>
                 </a:solidFill>
-                <a:latin typeface="Calibri" pitchFamily="34" charset="0"/>
-                <a:ea typeface="Calibri" pitchFamily="34" charset="-122"/>
-                <a:cs typeface="Calibri" pitchFamily="34" charset="-120"/>
+                <a:latin typeface="Fira Sans" pitchFamily="34" charset="0"/>
+                <a:ea typeface="Fira Sans" pitchFamily="34" charset="-122"/>
+                <a:cs typeface="Fira Sans" pitchFamily="34" charset="-120"/>
               </a:rPr>
               <a:t>Lektion 1</a:t>
             </a:r>
@@ -2117,9 +2117,9 @@
                 <a:solidFill>
                   <a:srgbClr val="3D3D5C"/>
                 </a:solidFill>
-                <a:latin typeface="Calibri" pitchFamily="34" charset="0"/>
-                <a:ea typeface="Calibri" pitchFamily="34" charset="-122"/>
-                <a:cs typeface="Calibri" pitchFamily="34" charset="-120"/>
+                <a:latin typeface="Fira Sans" pitchFamily="34" charset="0"/>
+                <a:ea typeface="Fira Sans" pitchFamily="34" charset="-122"/>
+                <a:cs typeface="Fira Sans" pitchFamily="34" charset="-120"/>
               </a:rPr>
               <a:t>Marketing neu denken</a:t>
             </a:r>
@@ -2156,9 +2156,9 @@
                 <a:solidFill>
                   <a:srgbClr val="893163"/>
                 </a:solidFill>
-                <a:latin typeface="Calibri" pitchFamily="34" charset="0"/>
-                <a:ea typeface="Calibri" pitchFamily="34" charset="-122"/>
-                <a:cs typeface="Calibri" pitchFamily="34" charset="-120"/>
+                <a:latin typeface="Fira Sans" pitchFamily="34" charset="0"/>
+                <a:ea typeface="Fira Sans" pitchFamily="34" charset="-122"/>
+                <a:cs typeface="Fira Sans" pitchFamily="34" charset="-120"/>
               </a:rPr>
               <a:t>Lektion 2</a:t>
             </a:r>
@@ -2195,9 +2195,9 @@
                 <a:solidFill>
                   <a:srgbClr val="3D3D5C"/>
                 </a:solidFill>
-                <a:latin typeface="Calibri" pitchFamily="34" charset="0"/>
-                <a:ea typeface="Calibri" pitchFamily="34" charset="-122"/>
-                <a:cs typeface="Calibri" pitchFamily="34" charset="-120"/>
+                <a:latin typeface="Fira Sans" pitchFamily="34" charset="0"/>
+                <a:ea typeface="Fira Sans" pitchFamily="34" charset="-122"/>
+                <a:cs typeface="Fira Sans" pitchFamily="34" charset="-120"/>
               </a:rPr>
               <a:t>Empfehlungen nutzen</a:t>
             </a:r>
@@ -2234,9 +2234,9 @@
                 <a:solidFill>
                   <a:srgbClr val="893163"/>
                 </a:solidFill>
-                <a:latin typeface="Calibri" pitchFamily="34" charset="0"/>
-                <a:ea typeface="Calibri" pitchFamily="34" charset="-122"/>
-                <a:cs typeface="Calibri" pitchFamily="34" charset="-120"/>
+                <a:latin typeface="Fira Sans" pitchFamily="34" charset="0"/>
+                <a:ea typeface="Fira Sans" pitchFamily="34" charset="-122"/>
+                <a:cs typeface="Fira Sans" pitchFamily="34" charset="-120"/>
               </a:rPr>
               <a:t>Lektion 3</a:t>
             </a:r>
@@ -2273,9 +2273,9 @@
                 <a:solidFill>
                   <a:srgbClr val="3D3D5C"/>
                 </a:solidFill>
-                <a:latin typeface="Calibri" pitchFamily="34" charset="0"/>
-                <a:ea typeface="Calibri" pitchFamily="34" charset="-122"/>
-                <a:cs typeface="Calibri" pitchFamily="34" charset="-120"/>
+                <a:latin typeface="Fira Sans" pitchFamily="34" charset="0"/>
+                <a:ea typeface="Fira Sans" pitchFamily="34" charset="-122"/>
+                <a:cs typeface="Fira Sans" pitchFamily="34" charset="-120"/>
               </a:rPr>
               <a:t>Kooperationen aufbauen</a:t>
             </a:r>
@@ -2312,9 +2312,9 @@
                 <a:solidFill>
                   <a:srgbClr val="893163"/>
                 </a:solidFill>
-                <a:latin typeface="Calibri" pitchFamily="34" charset="0"/>
-                <a:ea typeface="Calibri" pitchFamily="34" charset="-122"/>
-                <a:cs typeface="Calibri" pitchFamily="34" charset="-120"/>
+                <a:latin typeface="Fira Sans" pitchFamily="34" charset="0"/>
+                <a:ea typeface="Fira Sans" pitchFamily="34" charset="-122"/>
+                <a:cs typeface="Fira Sans" pitchFamily="34" charset="-120"/>
               </a:rPr>
               <a:t>Lektion 4</a:t>
             </a:r>
@@ -2351,9 +2351,9 @@
                 <a:solidFill>
                   <a:srgbClr val="3D3D5C"/>
                 </a:solidFill>
-                <a:latin typeface="Calibri" pitchFamily="34" charset="0"/>
-                <a:ea typeface="Calibri" pitchFamily="34" charset="-122"/>
-                <a:cs typeface="Calibri" pitchFamily="34" charset="-120"/>
+                <a:latin typeface="Fira Sans" pitchFamily="34" charset="0"/>
+                <a:ea typeface="Fira Sans" pitchFamily="34" charset="-122"/>
+                <a:cs typeface="Fira Sans" pitchFamily="34" charset="-120"/>
               </a:rPr>
               <a:t>Einfache Marketingmaßnahmen</a:t>
             </a:r>
@@ -2456,9 +2456,9 @@
                 <a:solidFill>
                   <a:srgbClr val="FFFFFF"/>
                 </a:solidFill>
-                <a:latin typeface="Calibri" pitchFamily="34" charset="0"/>
-                <a:ea typeface="Calibri" pitchFamily="34" charset="-122"/>
-                <a:cs typeface="Calibri" pitchFamily="34" charset="-120"/>
+                <a:latin typeface="Fira Sans" pitchFamily="34" charset="0"/>
+                <a:ea typeface="Fira Sans" pitchFamily="34" charset="-122"/>
+                <a:cs typeface="Fira Sans" pitchFamily="34" charset="-120"/>
               </a:rPr>
               <a:t>▶ 0:24</a:t>
             </a:r>
@@ -2561,9 +2561,9 @@
                 <a:solidFill>
                   <a:srgbClr val="FFFFFF"/>
                 </a:solidFill>
-                <a:latin typeface="Calibri" pitchFamily="34" charset="0"/>
-                <a:ea typeface="Calibri" pitchFamily="34" charset="-122"/>
-                <a:cs typeface="Calibri" pitchFamily="34" charset="-120"/>
+                <a:latin typeface="Fira Sans" pitchFamily="34" charset="0"/>
+                <a:ea typeface="Fira Sans" pitchFamily="34" charset="-122"/>
+                <a:cs typeface="Fira Sans" pitchFamily="34" charset="-120"/>
               </a:rPr>
               <a:t>▶ 0:24</a:t>
             </a:r>
@@ -2600,9 +2600,9 @@
                 <a:solidFill>
                   <a:srgbClr val="6B7280"/>
                 </a:solidFill>
-                <a:latin typeface="Calibri" pitchFamily="34" charset="0"/>
-                <a:ea typeface="Calibri" pitchFamily="34" charset="-122"/>
-                <a:cs typeface="Calibri" pitchFamily="34" charset="-120"/>
+                <a:latin typeface="Fira Sans" pitchFamily="34" charset="0"/>
+                <a:ea typeface="Fira Sans" pitchFamily="34" charset="-122"/>
+                <a:cs typeface="Fira Sans" pitchFamily="34" charset="-120"/>
               </a:rPr>
               <a:t>ELEVATOR42  –  SMARTER WAYS TO LEARN</a:t>
             </a:r>
@@ -2691,9 +2691,9 @@
                 <a:solidFill>
                   <a:srgbClr val="FFFFFF"/>
                 </a:solidFill>
-                <a:latin typeface="Calibri" pitchFamily="34" charset="0"/>
-                <a:ea typeface="Calibri" pitchFamily="34" charset="-122"/>
-                <a:cs typeface="Calibri" pitchFamily="34" charset="-120"/>
+                <a:latin typeface="Fira Sans" pitchFamily="34" charset="0"/>
+                <a:ea typeface="Fira Sans" pitchFamily="34" charset="-122"/>
+                <a:cs typeface="Fira Sans" pitchFamily="34" charset="-120"/>
               </a:rPr>
               <a:t>MODUL 9 · LEKTION 1</a:t>
             </a:r>
@@ -2754,9 +2754,9 @@
                 <a:solidFill>
                   <a:srgbClr val="6B7280"/>
                 </a:solidFill>
-                <a:latin typeface="Calibri" pitchFamily="34" charset="0"/>
-                <a:ea typeface="Calibri" pitchFamily="34" charset="-122"/>
-                <a:cs typeface="Calibri" pitchFamily="34" charset="-120"/>
+                <a:latin typeface="Fira Sans" pitchFamily="34" charset="0"/>
+                <a:ea typeface="Fira Sans" pitchFamily="34" charset="-122"/>
+                <a:cs typeface="Fira Sans" pitchFamily="34" charset="-120"/>
               </a:rPr>
               <a:t>ELEVATOR42  –  SMARTER WAYS TO LEARN</a:t>
             </a:r>
@@ -2793,9 +2793,9 @@
                 <a:solidFill>
                   <a:srgbClr val="1F4E79"/>
                 </a:solidFill>
-                <a:latin typeface="Georgia" pitchFamily="34" charset="0"/>
-                <a:ea typeface="Georgia" pitchFamily="34" charset="-122"/>
-                <a:cs typeface="Georgia" pitchFamily="34" charset="-120"/>
+                <a:latin typeface="Fira Sans SemiBold" pitchFamily="34" charset="0"/>
+                <a:ea typeface="Fira Sans SemiBold" pitchFamily="34" charset="-122"/>
+                <a:cs typeface="Fira Sans SemiBold" pitchFamily="34" charset="-120"/>
               </a:rPr>
               <a:t>Marketing neu denken</a:t>
             </a:r>
@@ -2879,9 +2879,9 @@
                 <a:solidFill>
                   <a:srgbClr val="FFFFFF"/>
                 </a:solidFill>
-                <a:latin typeface="Georgia" pitchFamily="34" charset="0"/>
-                <a:ea typeface="Georgia" pitchFamily="34" charset="-122"/>
-                <a:cs typeface="Georgia" pitchFamily="34" charset="-120"/>
+                <a:latin typeface="Fira Sans SemiBold" pitchFamily="34" charset="0"/>
+                <a:ea typeface="Fira Sans SemiBold" pitchFamily="34" charset="-122"/>
+                <a:cs typeface="Fira Sans SemiBold" pitchFamily="34" charset="-120"/>
               </a:rPr>
               <a:t>Marketing ≠</a:t>
             </a:r>
@@ -2918,9 +2918,9 @@
                 <a:solidFill>
                   <a:srgbClr val="D6DCE5"/>
                 </a:solidFill>
-                <a:latin typeface="Calibri" pitchFamily="34" charset="0"/>
-                <a:ea typeface="Calibri" pitchFamily="34" charset="-122"/>
-                <a:cs typeface="Calibri" pitchFamily="34" charset="-120"/>
+                <a:latin typeface="Fira Sans" pitchFamily="34" charset="0"/>
+                <a:ea typeface="Fira Sans" pitchFamily="34" charset="-122"/>
+                <a:cs typeface="Fira Sans" pitchFamily="34" charset="-120"/>
               </a:rPr>
               <a:t>▸ Werbung machen</a:t>
             </a:r>
@@ -2957,9 +2957,9 @@
                 <a:solidFill>
                   <a:srgbClr val="D6DCE5"/>
                 </a:solidFill>
-                <a:latin typeface="Calibri" pitchFamily="34" charset="0"/>
-                <a:ea typeface="Calibri" pitchFamily="34" charset="-122"/>
-                <a:cs typeface="Calibri" pitchFamily="34" charset="-120"/>
+                <a:latin typeface="Fira Sans" pitchFamily="34" charset="0"/>
+                <a:ea typeface="Fira Sans" pitchFamily="34" charset="-122"/>
+                <a:cs typeface="Fira Sans" pitchFamily="34" charset="-120"/>
               </a:rPr>
               <a:t>▸ Menschen überzeugen</a:t>
             </a:r>
@@ -2996,9 +2996,9 @@
                 <a:solidFill>
                   <a:srgbClr val="D6DCE5"/>
                 </a:solidFill>
-                <a:latin typeface="Calibri" pitchFamily="34" charset="0"/>
-                <a:ea typeface="Calibri" pitchFamily="34" charset="-122"/>
-                <a:cs typeface="Calibri" pitchFamily="34" charset="-120"/>
+                <a:latin typeface="Fira Sans" pitchFamily="34" charset="0"/>
+                <a:ea typeface="Fira Sans" pitchFamily="34" charset="-122"/>
+                <a:cs typeface="Fira Sans" pitchFamily="34" charset="-120"/>
               </a:rPr>
               <a:t>▸ Aufdringlich sein</a:t>
             </a:r>
@@ -3035,9 +3035,9 @@
                 <a:solidFill>
                   <a:srgbClr val="D6DCE5"/>
                 </a:solidFill>
-                <a:latin typeface="Calibri" pitchFamily="34" charset="0"/>
-                <a:ea typeface="Calibri" pitchFamily="34" charset="-122"/>
-                <a:cs typeface="Calibri" pitchFamily="34" charset="-120"/>
+                <a:latin typeface="Fira Sans" pitchFamily="34" charset="0"/>
+                <a:ea typeface="Fira Sans" pitchFamily="34" charset="-122"/>
+                <a:cs typeface="Fira Sans" pitchFamily="34" charset="-120"/>
               </a:rPr>
               <a:t>▸ Social Media um jeden Preis</a:t>
             </a:r>
@@ -3121,9 +3121,9 @@
                 <a:solidFill>
                   <a:srgbClr val="FFFFFF"/>
                 </a:solidFill>
-                <a:latin typeface="Georgia" pitchFamily="34" charset="0"/>
-                <a:ea typeface="Georgia" pitchFamily="34" charset="-122"/>
-                <a:cs typeface="Georgia" pitchFamily="34" charset="-120"/>
+                <a:latin typeface="Fira Sans SemiBold" pitchFamily="34" charset="0"/>
+                <a:ea typeface="Fira Sans SemiBold" pitchFamily="34" charset="-122"/>
+                <a:cs typeface="Fira Sans SemiBold" pitchFamily="34" charset="-120"/>
               </a:rPr>
               <a:t>Marketing =</a:t>
             </a:r>
@@ -3160,9 +3160,9 @@
                 <a:solidFill>
                   <a:srgbClr val="D6DCE5"/>
                 </a:solidFill>
-                <a:latin typeface="Calibri" pitchFamily="34" charset="0"/>
-                <a:ea typeface="Calibri" pitchFamily="34" charset="-122"/>
-                <a:cs typeface="Calibri" pitchFamily="34" charset="-120"/>
+                <a:latin typeface="Fira Sans" pitchFamily="34" charset="0"/>
+                <a:ea typeface="Fira Sans" pitchFamily="34" charset="-122"/>
+                <a:cs typeface="Fira Sans" pitchFamily="34" charset="-120"/>
               </a:rPr>
               <a:t>▸ Vertrauen aufbauen</a:t>
             </a:r>
@@ -3199,9 +3199,9 @@
                 <a:solidFill>
                   <a:srgbClr val="D6DCE5"/>
                 </a:solidFill>
-                <a:latin typeface="Calibri" pitchFamily="34" charset="0"/>
-                <a:ea typeface="Calibri" pitchFamily="34" charset="-122"/>
-                <a:cs typeface="Calibri" pitchFamily="34" charset="-120"/>
+                <a:latin typeface="Fira Sans" pitchFamily="34" charset="0"/>
+                <a:ea typeface="Fira Sans" pitchFamily="34" charset="-122"/>
+                <a:cs typeface="Fira Sans" pitchFamily="34" charset="-120"/>
               </a:rPr>
               <a:t>▸ Sichtbarkeit schaffen</a:t>
             </a:r>
@@ -3238,9 +3238,9 @@
                 <a:solidFill>
                   <a:srgbClr val="D6DCE5"/>
                 </a:solidFill>
-                <a:latin typeface="Calibri" pitchFamily="34" charset="0"/>
-                <a:ea typeface="Calibri" pitchFamily="34" charset="-122"/>
-                <a:cs typeface="Calibri" pitchFamily="34" charset="-120"/>
+                <a:latin typeface="Fira Sans" pitchFamily="34" charset="0"/>
+                <a:ea typeface="Fira Sans" pitchFamily="34" charset="-122"/>
+                <a:cs typeface="Fira Sans" pitchFamily="34" charset="-120"/>
               </a:rPr>
               <a:t>▸ Hilfe bei der Entscheidung</a:t>
             </a:r>
@@ -3277,9 +3277,9 @@
                 <a:solidFill>
                   <a:srgbClr val="D6DCE5"/>
                 </a:solidFill>
-                <a:latin typeface="Calibri" pitchFamily="34" charset="0"/>
-                <a:ea typeface="Calibri" pitchFamily="34" charset="-122"/>
-                <a:cs typeface="Calibri" pitchFamily="34" charset="-120"/>
+                <a:latin typeface="Fira Sans" pitchFamily="34" charset="0"/>
+                <a:ea typeface="Fira Sans" pitchFamily="34" charset="-122"/>
+                <a:cs typeface="Fira Sans" pitchFamily="34" charset="-120"/>
               </a:rPr>
               <a:t>▸ Langfristige Beziehungen</a:t>
             </a:r>
@@ -3356,9 +3356,9 @@
                 <a:solidFill>
                   <a:srgbClr val="893163"/>
                 </a:solidFill>
-                <a:latin typeface="Calibri" pitchFamily="34" charset="0"/>
-                <a:ea typeface="Calibri" pitchFamily="34" charset="-122"/>
-                <a:cs typeface="Calibri" pitchFamily="34" charset="-120"/>
+                <a:latin typeface="Fira Sans" pitchFamily="34" charset="0"/>
+                <a:ea typeface="Fira Sans" pitchFamily="34" charset="-122"/>
+                <a:cs typeface="Fira Sans" pitchFamily="34" charset="-120"/>
               </a:rPr>
               <a:t>Marketing heißt: Menschen helfen, die richtige Entscheidung zu treffen.</a:t>
             </a:r>
@@ -3461,9 +3461,9 @@
                 <a:solidFill>
                   <a:srgbClr val="FFFFFF"/>
                 </a:solidFill>
-                <a:latin typeface="Calibri" pitchFamily="34" charset="0"/>
-                <a:ea typeface="Calibri" pitchFamily="34" charset="-122"/>
-                <a:cs typeface="Calibri" pitchFamily="34" charset="-120"/>
+                <a:latin typeface="Fira Sans" pitchFamily="34" charset="0"/>
+                <a:ea typeface="Fira Sans" pitchFamily="34" charset="-122"/>
+                <a:cs typeface="Fira Sans" pitchFamily="34" charset="-120"/>
               </a:rPr>
               <a:t>▶ 0:24</a:t>
             </a:r>
@@ -3552,9 +3552,9 @@
                 <a:solidFill>
                   <a:srgbClr val="FFFFFF"/>
                 </a:solidFill>
-                <a:latin typeface="Calibri" pitchFamily="34" charset="0"/>
-                <a:ea typeface="Calibri" pitchFamily="34" charset="-122"/>
-                <a:cs typeface="Calibri" pitchFamily="34" charset="-120"/>
+                <a:latin typeface="Fira Sans" pitchFamily="34" charset="0"/>
+                <a:ea typeface="Fira Sans" pitchFamily="34" charset="-122"/>
+                <a:cs typeface="Fira Sans" pitchFamily="34" charset="-120"/>
               </a:rPr>
               <a:t>MODUL 9 · LEKTION 2-3</a:t>
             </a:r>
@@ -3615,9 +3615,9 @@
                 <a:solidFill>
                   <a:srgbClr val="6B7280"/>
                 </a:solidFill>
-                <a:latin typeface="Calibri" pitchFamily="34" charset="0"/>
-                <a:ea typeface="Calibri" pitchFamily="34" charset="-122"/>
-                <a:cs typeface="Calibri" pitchFamily="34" charset="-120"/>
+                <a:latin typeface="Fira Sans" pitchFamily="34" charset="0"/>
+                <a:ea typeface="Fira Sans" pitchFamily="34" charset="-122"/>
+                <a:cs typeface="Fira Sans" pitchFamily="34" charset="-120"/>
               </a:rPr>
               <a:t>ELEVATOR42  –  SMARTER WAYS TO LEARN</a:t>
             </a:r>
@@ -3654,9 +3654,9 @@
                 <a:solidFill>
                   <a:srgbClr val="1F4E79"/>
                 </a:solidFill>
-                <a:latin typeface="Georgia" pitchFamily="34" charset="0"/>
-                <a:ea typeface="Georgia" pitchFamily="34" charset="-122"/>
-                <a:cs typeface="Georgia" pitchFamily="34" charset="-120"/>
+                <a:latin typeface="Fira Sans SemiBold" pitchFamily="34" charset="0"/>
+                <a:ea typeface="Fira Sans SemiBold" pitchFamily="34" charset="-122"/>
+                <a:cs typeface="Fira Sans SemiBold" pitchFamily="34" charset="-120"/>
               </a:rPr>
               <a:t>Empfehlungen &amp; Kooperationen</a:t>
             </a:r>
@@ -3713,9 +3713,9 @@
                 <a:solidFill>
                   <a:srgbClr val="FFFFFF"/>
                 </a:solidFill>
-                <a:latin typeface="Georgia" pitchFamily="34" charset="0"/>
-                <a:ea typeface="Georgia" pitchFamily="34" charset="-122"/>
-                <a:cs typeface="Georgia" pitchFamily="34" charset="-120"/>
+                <a:latin typeface="Fira Sans SemiBold" pitchFamily="34" charset="0"/>
+                <a:ea typeface="Fira Sans SemiBold" pitchFamily="34" charset="-122"/>
+                <a:cs typeface="Fira Sans SemiBold" pitchFamily="34" charset="-120"/>
               </a:rPr>
               <a:t>1</a:t>
             </a:r>
@@ -3779,9 +3779,9 @@
                 <a:solidFill>
                   <a:srgbClr val="FFFFFF"/>
                 </a:solidFill>
-                <a:latin typeface="Georgia" pitchFamily="34" charset="0"/>
-                <a:ea typeface="Georgia" pitchFamily="34" charset="-122"/>
-                <a:cs typeface="Georgia" pitchFamily="34" charset="-120"/>
+                <a:latin typeface="Fira Sans SemiBold" pitchFamily="34" charset="0"/>
+                <a:ea typeface="Fira Sans SemiBold" pitchFamily="34" charset="-122"/>
+                <a:cs typeface="Fira Sans SemiBold" pitchFamily="34" charset="-120"/>
               </a:rPr>
               <a:t>Bewertungen aktiv einholen</a:t>
             </a:r>
@@ -3818,9 +3818,9 @@
                 <a:solidFill>
                   <a:srgbClr val="D6DCE5"/>
                 </a:solidFill>
-                <a:latin typeface="Calibri" pitchFamily="34" charset="0"/>
-                <a:ea typeface="Calibri" pitchFamily="34" charset="-122"/>
-                <a:cs typeface="Calibri" pitchFamily="34" charset="-120"/>
+                <a:latin typeface="Fira Sans" pitchFamily="34" charset="0"/>
+                <a:ea typeface="Fira Sans" pitchFamily="34" charset="-122"/>
+                <a:cs typeface="Fira Sans" pitchFamily="34" charset="-120"/>
               </a:rPr>
               <a:t>Zufriedene Patienten gezielt ansprechen</a:t>
             </a:r>
@@ -3877,9 +3877,9 @@
                 <a:solidFill>
                   <a:srgbClr val="FFFFFF"/>
                 </a:solidFill>
-                <a:latin typeface="Georgia" pitchFamily="34" charset="0"/>
-                <a:ea typeface="Georgia" pitchFamily="34" charset="-122"/>
-                <a:cs typeface="Georgia" pitchFamily="34" charset="-120"/>
+                <a:latin typeface="Fira Sans SemiBold" pitchFamily="34" charset="0"/>
+                <a:ea typeface="Fira Sans SemiBold" pitchFamily="34" charset="-122"/>
+                <a:cs typeface="Fira Sans SemiBold" pitchFamily="34" charset="-120"/>
               </a:rPr>
               <a:t>2</a:t>
             </a:r>
@@ -3943,9 +3943,9 @@
                 <a:solidFill>
                   <a:srgbClr val="FFFFFF"/>
                 </a:solidFill>
-                <a:latin typeface="Georgia" pitchFamily="34" charset="0"/>
-                <a:ea typeface="Georgia" pitchFamily="34" charset="-122"/>
-                <a:cs typeface="Georgia" pitchFamily="34" charset="-120"/>
+                <a:latin typeface="Fira Sans SemiBold" pitchFamily="34" charset="0"/>
+                <a:ea typeface="Fira Sans SemiBold" pitchFamily="34" charset="-122"/>
+                <a:cs typeface="Fira Sans SemiBold" pitchFamily="34" charset="-120"/>
               </a:rPr>
               <a:t>Empfehlungsprogramm starten</a:t>
             </a:r>
@@ -3982,9 +3982,9 @@
                 <a:solidFill>
                   <a:srgbClr val="D6DCE5"/>
                 </a:solidFill>
-                <a:latin typeface="Calibri" pitchFamily="34" charset="0"/>
-                <a:ea typeface="Calibri" pitchFamily="34" charset="-122"/>
-                <a:cs typeface="Calibri" pitchFamily="34" charset="-120"/>
+                <a:latin typeface="Fira Sans" pitchFamily="34" charset="0"/>
+                <a:ea typeface="Fira Sans" pitchFamily="34" charset="-122"/>
+                <a:cs typeface="Fira Sans" pitchFamily="34" charset="-120"/>
               </a:rPr>
               <a:t>Einfacher Mechanismus für Weiterempfehlung</a:t>
             </a:r>
@@ -4041,9 +4041,9 @@
                 <a:solidFill>
                   <a:srgbClr val="FFFFFF"/>
                 </a:solidFill>
-                <a:latin typeface="Georgia" pitchFamily="34" charset="0"/>
-                <a:ea typeface="Georgia" pitchFamily="34" charset="-122"/>
-                <a:cs typeface="Georgia" pitchFamily="34" charset="-120"/>
+                <a:latin typeface="Fira Sans SemiBold" pitchFamily="34" charset="0"/>
+                <a:ea typeface="Fira Sans SemiBold" pitchFamily="34" charset="-122"/>
+                <a:cs typeface="Fira Sans SemiBold" pitchFamily="34" charset="-120"/>
               </a:rPr>
               <a:t>3</a:t>
             </a:r>
@@ -4107,9 +4107,9 @@
                 <a:solidFill>
                   <a:srgbClr val="FFFFFF"/>
                 </a:solidFill>
-                <a:latin typeface="Georgia" pitchFamily="34" charset="0"/>
-                <a:ea typeface="Georgia" pitchFamily="34" charset="-122"/>
-                <a:cs typeface="Georgia" pitchFamily="34" charset="-120"/>
+                <a:latin typeface="Fira Sans SemiBold" pitchFamily="34" charset="0"/>
+                <a:ea typeface="Fira Sans SemiBold" pitchFamily="34" charset="-122"/>
+                <a:cs typeface="Fira Sans SemiBold" pitchFamily="34" charset="-120"/>
               </a:rPr>
               <a:t>Kooperationspartner finden</a:t>
             </a:r>
@@ -4146,9 +4146,9 @@
                 <a:solidFill>
                   <a:srgbClr val="D6DCE5"/>
                 </a:solidFill>
-                <a:latin typeface="Calibri" pitchFamily="34" charset="0"/>
-                <a:ea typeface="Calibri" pitchFamily="34" charset="-122"/>
-                <a:cs typeface="Calibri" pitchFamily="34" charset="-120"/>
+                <a:latin typeface="Fira Sans" pitchFamily="34" charset="0"/>
+                <a:ea typeface="Fira Sans" pitchFamily="34" charset="-122"/>
+                <a:cs typeface="Fira Sans" pitchFamily="34" charset="-120"/>
               </a:rPr>
               <a:t>Gemeinsame Zielgruppe, gemeinsamer Mehrwert</a:t>
             </a:r>
@@ -4205,9 +4205,9 @@
                 <a:solidFill>
                   <a:srgbClr val="FFFFFF"/>
                 </a:solidFill>
-                <a:latin typeface="Georgia" pitchFamily="34" charset="0"/>
-                <a:ea typeface="Georgia" pitchFamily="34" charset="-122"/>
-                <a:cs typeface="Georgia" pitchFamily="34" charset="-120"/>
+                <a:latin typeface="Fira Sans SemiBold" pitchFamily="34" charset="0"/>
+                <a:ea typeface="Fira Sans SemiBold" pitchFamily="34" charset="-122"/>
+                <a:cs typeface="Fira Sans SemiBold" pitchFamily="34" charset="-120"/>
               </a:rPr>
               <a:t>4</a:t>
             </a:r>
@@ -4271,9 +4271,9 @@
                 <a:solidFill>
                   <a:srgbClr val="FFFFFF"/>
                 </a:solidFill>
-                <a:latin typeface="Georgia" pitchFamily="34" charset="0"/>
-                <a:ea typeface="Georgia" pitchFamily="34" charset="-122"/>
-                <a:cs typeface="Georgia" pitchFamily="34" charset="-120"/>
+                <a:latin typeface="Fira Sans SemiBold" pitchFamily="34" charset="0"/>
+                <a:ea typeface="Fira Sans SemiBold" pitchFamily="34" charset="-122"/>
+                <a:cs typeface="Fira Sans SemiBold" pitchFamily="34" charset="-120"/>
               </a:rPr>
               <a:t>Netzwerk pflegen</a:t>
             </a:r>
@@ -4310,9 +4310,9 @@
                 <a:solidFill>
                   <a:srgbClr val="D6DCE5"/>
                 </a:solidFill>
-                <a:latin typeface="Calibri" pitchFamily="34" charset="0"/>
-                <a:ea typeface="Calibri" pitchFamily="34" charset="-122"/>
-                <a:cs typeface="Calibri" pitchFamily="34" charset="-120"/>
+                <a:latin typeface="Fira Sans" pitchFamily="34" charset="0"/>
+                <a:ea typeface="Fira Sans" pitchFamily="34" charset="-122"/>
+                <a:cs typeface="Fira Sans" pitchFamily="34" charset="-120"/>
               </a:rPr>
               <a:t>Regelmäßiger Austausch mit Partnern</a:t>
             </a:r>
@@ -4415,9 +4415,9 @@
                 <a:solidFill>
                   <a:srgbClr val="FFFFFF"/>
                 </a:solidFill>
-                <a:latin typeface="Calibri" pitchFamily="34" charset="0"/>
-                <a:ea typeface="Calibri" pitchFamily="34" charset="-122"/>
-                <a:cs typeface="Calibri" pitchFamily="34" charset="-120"/>
+                <a:latin typeface="Fira Sans" pitchFamily="34" charset="0"/>
+                <a:ea typeface="Fira Sans" pitchFamily="34" charset="-122"/>
+                <a:cs typeface="Fira Sans" pitchFamily="34" charset="-120"/>
               </a:rPr>
               <a:t>▶ 0:24</a:t>
             </a:r>
@@ -4506,9 +4506,9 @@
                 <a:solidFill>
                   <a:srgbClr val="FFFFFF"/>
                 </a:solidFill>
-                <a:latin typeface="Calibri" pitchFamily="34" charset="0"/>
-                <a:ea typeface="Calibri" pitchFamily="34" charset="-122"/>
-                <a:cs typeface="Calibri" pitchFamily="34" charset="-120"/>
+                <a:latin typeface="Fira Sans" pitchFamily="34" charset="0"/>
+                <a:ea typeface="Fira Sans" pitchFamily="34" charset="-122"/>
+                <a:cs typeface="Fira Sans" pitchFamily="34" charset="-120"/>
               </a:rPr>
               <a:t>MODUL 9 · LEKTION 4</a:t>
             </a:r>
@@ -4569,9 +4569,9 @@
                 <a:solidFill>
                   <a:srgbClr val="6B7280"/>
                 </a:solidFill>
-                <a:latin typeface="Calibri" pitchFamily="34" charset="0"/>
-                <a:ea typeface="Calibri" pitchFamily="34" charset="-122"/>
-                <a:cs typeface="Calibri" pitchFamily="34" charset="-120"/>
+                <a:latin typeface="Fira Sans" pitchFamily="34" charset="0"/>
+                <a:ea typeface="Fira Sans" pitchFamily="34" charset="-122"/>
+                <a:cs typeface="Fira Sans" pitchFamily="34" charset="-120"/>
               </a:rPr>
               <a:t>ELEVATOR42  –  SMARTER WAYS TO LEARN</a:t>
             </a:r>
@@ -4608,9 +4608,9 @@
                 <a:solidFill>
                   <a:srgbClr val="1F4E79"/>
                 </a:solidFill>
-                <a:latin typeface="Georgia" pitchFamily="34" charset="0"/>
-                <a:ea typeface="Georgia" pitchFamily="34" charset="-122"/>
-                <a:cs typeface="Georgia" pitchFamily="34" charset="-120"/>
+                <a:latin typeface="Fira Sans SemiBold" pitchFamily="34" charset="0"/>
+                <a:ea typeface="Fira Sans SemiBold" pitchFamily="34" charset="-122"/>
+                <a:cs typeface="Fira Sans SemiBold" pitchFamily="34" charset="-120"/>
               </a:rPr>
               <a:t>Das Marketing-System</a:t>
             </a:r>
@@ -4674,9 +4674,9 @@
                 <a:solidFill>
                   <a:srgbClr val="FFFFFF"/>
                 </a:solidFill>
-                <a:latin typeface="Georgia" pitchFamily="34" charset="0"/>
-                <a:ea typeface="Georgia" pitchFamily="34" charset="-122"/>
-                <a:cs typeface="Georgia" pitchFamily="34" charset="-120"/>
+                <a:latin typeface="Fira Sans SemiBold" pitchFamily="34" charset="0"/>
+                <a:ea typeface="Fira Sans SemiBold" pitchFamily="34" charset="-122"/>
+                <a:cs typeface="Fira Sans SemiBold" pitchFamily="34" charset="-120"/>
               </a:rPr>
               <a:t>Empfehlung &amp; Wachstum</a:t>
             </a:r>
@@ -4713,9 +4713,9 @@
                 <a:solidFill>
                   <a:srgbClr val="D6DCE5"/>
                 </a:solidFill>
-                <a:latin typeface="Calibri" pitchFamily="34" charset="0"/>
-                <a:ea typeface="Calibri" pitchFamily="34" charset="-122"/>
-                <a:cs typeface="Calibri" pitchFamily="34" charset="-120"/>
+                <a:latin typeface="Fira Sans" pitchFamily="34" charset="0"/>
+                <a:ea typeface="Fira Sans" pitchFamily="34" charset="-122"/>
+                <a:cs typeface="Fira Sans" pitchFamily="34" charset="-120"/>
               </a:rPr>
               <a:t>Systematisch neue Patienten gewinnen</a:t>
             </a:r>
@@ -4779,9 +4779,9 @@
                 <a:solidFill>
                   <a:srgbClr val="FFFFFF"/>
                 </a:solidFill>
-                <a:latin typeface="Georgia" pitchFamily="34" charset="0"/>
-                <a:ea typeface="Georgia" pitchFamily="34" charset="-122"/>
-                <a:cs typeface="Georgia" pitchFamily="34" charset="-120"/>
+                <a:latin typeface="Fira Sans SemiBold" pitchFamily="34" charset="0"/>
+                <a:ea typeface="Fira Sans SemiBold" pitchFamily="34" charset="-122"/>
+                <a:cs typeface="Fira Sans SemiBold" pitchFamily="34" charset="-120"/>
               </a:rPr>
               <a:t>Vertrauen aufbauen</a:t>
             </a:r>
@@ -4818,9 +4818,9 @@
                 <a:solidFill>
                   <a:srgbClr val="D6DCE5"/>
                 </a:solidFill>
-                <a:latin typeface="Calibri" pitchFamily="34" charset="0"/>
-                <a:ea typeface="Calibri" pitchFamily="34" charset="-122"/>
-                <a:cs typeface="Calibri" pitchFamily="34" charset="-120"/>
+                <a:latin typeface="Fira Sans" pitchFamily="34" charset="0"/>
+                <a:ea typeface="Fira Sans" pitchFamily="34" charset="-122"/>
+                <a:cs typeface="Fira Sans" pitchFamily="34" charset="-120"/>
               </a:rPr>
               <a:t>Team schulen, Kommunikation optimieren</a:t>
             </a:r>
@@ -4884,9 +4884,9 @@
                 <a:solidFill>
                   <a:srgbClr val="FFFFFF"/>
                 </a:solidFill>
-                <a:latin typeface="Georgia" pitchFamily="34" charset="0"/>
-                <a:ea typeface="Georgia" pitchFamily="34" charset="-122"/>
-                <a:cs typeface="Georgia" pitchFamily="34" charset="-120"/>
+                <a:latin typeface="Fira Sans SemiBold" pitchFamily="34" charset="0"/>
+                <a:ea typeface="Fira Sans SemiBold" pitchFamily="34" charset="-122"/>
+                <a:cs typeface="Fira Sans SemiBold" pitchFamily="34" charset="-120"/>
               </a:rPr>
               <a:t>Sichtbarkeit schaffen</a:t>
             </a:r>
@@ -4923,9 +4923,9 @@
                 <a:solidFill>
                   <a:srgbClr val="D6DCE5"/>
                 </a:solidFill>
-                <a:latin typeface="Calibri" pitchFamily="34" charset="0"/>
-                <a:ea typeface="Calibri" pitchFamily="34" charset="-122"/>
-                <a:cs typeface="Calibri" pitchFamily="34" charset="-120"/>
+                <a:latin typeface="Fira Sans" pitchFamily="34" charset="0"/>
+                <a:ea typeface="Fira Sans" pitchFamily="34" charset="-122"/>
+                <a:cs typeface="Fira Sans" pitchFamily="34" charset="-120"/>
               </a:rPr>
               <a:t>Website, Google, Bewertungen</a:t>
             </a:r>
@@ -4962,9 +4962,9 @@
                 <a:solidFill>
                   <a:srgbClr val="893163"/>
                 </a:solidFill>
-                <a:latin typeface="Calibri" pitchFamily="34" charset="0"/>
-                <a:ea typeface="Calibri" pitchFamily="34" charset="-122"/>
-                <a:cs typeface="Calibri" pitchFamily="34" charset="-120"/>
+                <a:latin typeface="Fira Sans" pitchFamily="34" charset="0"/>
+                <a:ea typeface="Fira Sans" pitchFamily="34" charset="-122"/>
+                <a:cs typeface="Fira Sans" pitchFamily="34" charset="-120"/>
               </a:rPr>
               <a:t>Phase 1: Sichtbarkeit</a:t>
             </a:r>
@@ -4979,9 +4979,9 @@
                 <a:solidFill>
                   <a:srgbClr val="893163"/>
                 </a:solidFill>
-                <a:latin typeface="Calibri" pitchFamily="34" charset="0"/>
-                <a:ea typeface="Calibri" pitchFamily="34" charset="-122"/>
-                <a:cs typeface="Calibri" pitchFamily="34" charset="-120"/>
+                <a:latin typeface="Fira Sans" pitchFamily="34" charset="0"/>
+                <a:ea typeface="Fira Sans" pitchFamily="34" charset="-122"/>
+                <a:cs typeface="Fira Sans" pitchFamily="34" charset="-120"/>
               </a:rPr>
               <a:t>Phase 2: Vertrauen</a:t>
             </a:r>
@@ -4996,9 +4996,9 @@
                 <a:solidFill>
                   <a:srgbClr val="893163"/>
                 </a:solidFill>
-                <a:latin typeface="Calibri" pitchFamily="34" charset="0"/>
-                <a:ea typeface="Calibri" pitchFamily="34" charset="-122"/>
-                <a:cs typeface="Calibri" pitchFamily="34" charset="-120"/>
+                <a:latin typeface="Fira Sans" pitchFamily="34" charset="0"/>
+                <a:ea typeface="Fira Sans" pitchFamily="34" charset="-122"/>
+                <a:cs typeface="Fira Sans" pitchFamily="34" charset="-120"/>
               </a:rPr>
               <a:t>Phase 3: Wachstum</a:t>
             </a:r>
@@ -5013,9 +5013,9 @@
                 <a:solidFill>
                   <a:srgbClr val="893163"/>
                 </a:solidFill>
-                <a:latin typeface="Calibri" pitchFamily="34" charset="0"/>
-                <a:ea typeface="Calibri" pitchFamily="34" charset="-122"/>
-                <a:cs typeface="Calibri" pitchFamily="34" charset="-120"/>
+                <a:latin typeface="Fira Sans" pitchFamily="34" charset="0"/>
+                <a:ea typeface="Fira Sans" pitchFamily="34" charset="-122"/>
+                <a:cs typeface="Fira Sans" pitchFamily="34" charset="-120"/>
               </a:rPr>
               <a:t>= 3-Monats-Blueprint</a:t>
             </a:r>
@@ -5118,9 +5118,9 @@
                 <a:solidFill>
                   <a:srgbClr val="FFFFFF"/>
                 </a:solidFill>
-                <a:latin typeface="Calibri" pitchFamily="34" charset="0"/>
-                <a:ea typeface="Calibri" pitchFamily="34" charset="-122"/>
-                <a:cs typeface="Calibri" pitchFamily="34" charset="-120"/>
+                <a:latin typeface="Fira Sans" pitchFamily="34" charset="0"/>
+                <a:ea typeface="Fira Sans" pitchFamily="34" charset="-122"/>
+                <a:cs typeface="Fira Sans" pitchFamily="34" charset="-120"/>
               </a:rPr>
               <a:t>▶ 0:24</a:t>
             </a:r>
@@ -5233,9 +5233,9 @@
                 <a:solidFill>
                   <a:srgbClr val="3D3D5C"/>
                 </a:solidFill>
-                <a:latin typeface="Calibri" pitchFamily="34" charset="0"/>
-                <a:ea typeface="Calibri" pitchFamily="34" charset="-122"/>
-                <a:cs typeface="Calibri" pitchFamily="34" charset="-120"/>
+                <a:latin typeface="Fira Sans" pitchFamily="34" charset="0"/>
+                <a:ea typeface="Fira Sans" pitchFamily="34" charset="-122"/>
+                <a:cs typeface="Fira Sans" pitchFamily="34" charset="-120"/>
               </a:rPr>
               <a:t>Kernbotschaft Modul 9</a:t>
             </a:r>
@@ -5272,9 +5272,9 @@
                 <a:solidFill>
                   <a:srgbClr val="893163"/>
                 </a:solidFill>
-                <a:latin typeface="Georgia" pitchFamily="34" charset="0"/>
-                <a:ea typeface="Georgia" pitchFamily="34" charset="-122"/>
-                <a:cs typeface="Georgia" pitchFamily="34" charset="-120"/>
+                <a:latin typeface="Fira Sans SemiBold" pitchFamily="34" charset="0"/>
+                <a:ea typeface="Fira Sans SemiBold" pitchFamily="34" charset="-122"/>
+                <a:cs typeface="Fira Sans SemiBold" pitchFamily="34" charset="-120"/>
               </a:rPr>
               <a:t>Marketing bedeutet nicht,</a:t>
             </a:r>
@@ -5289,9 +5289,9 @@
                 <a:solidFill>
                   <a:srgbClr val="893163"/>
                 </a:solidFill>
-                <a:latin typeface="Georgia" pitchFamily="34" charset="0"/>
-                <a:ea typeface="Georgia" pitchFamily="34" charset="-122"/>
-                <a:cs typeface="Georgia" pitchFamily="34" charset="-120"/>
+                <a:latin typeface="Fira Sans SemiBold" pitchFamily="34" charset="0"/>
+                <a:ea typeface="Fira Sans SemiBold" pitchFamily="34" charset="-122"/>
+                <a:cs typeface="Fira Sans SemiBold" pitchFamily="34" charset="-120"/>
               </a:rPr>
               <a:t>Menschen zu überzeugen.</a:t>
             </a:r>
@@ -5350,9 +5350,9 @@
                 <a:solidFill>
                   <a:srgbClr val="893163"/>
                 </a:solidFill>
-                <a:latin typeface="Georgia" pitchFamily="34" charset="0"/>
-                <a:ea typeface="Georgia" pitchFamily="34" charset="-122"/>
-                <a:cs typeface="Georgia" pitchFamily="34" charset="-120"/>
+                <a:latin typeface="Fira Sans SemiBold" pitchFamily="34" charset="0"/>
+                <a:ea typeface="Fira Sans SemiBold" pitchFamily="34" charset="-122"/>
+                <a:cs typeface="Fira Sans SemiBold" pitchFamily="34" charset="-120"/>
               </a:rPr>
               <a:t>Sondern ihnen zu helfen,</a:t>
             </a:r>
@@ -5367,9 +5367,9 @@
                 <a:solidFill>
                   <a:srgbClr val="893163"/>
                 </a:solidFill>
-                <a:latin typeface="Georgia" pitchFamily="34" charset="0"/>
-                <a:ea typeface="Georgia" pitchFamily="34" charset="-122"/>
-                <a:cs typeface="Georgia" pitchFamily="34" charset="-120"/>
+                <a:latin typeface="Fira Sans SemiBold" pitchFamily="34" charset="0"/>
+                <a:ea typeface="Fira Sans SemiBold" pitchFamily="34" charset="-122"/>
+                <a:cs typeface="Fira Sans SemiBold" pitchFamily="34" charset="-120"/>
               </a:rPr>
               <a:t>die richtige Entscheidung zu treffen.</a:t>
             </a:r>
@@ -5433,9 +5433,9 @@
                 <a:solidFill>
                   <a:srgbClr val="1A1A2E"/>
                 </a:solidFill>
-                <a:latin typeface="Calibri" pitchFamily="34" charset="0"/>
-                <a:ea typeface="Calibri" pitchFamily="34" charset="-122"/>
-                <a:cs typeface="Calibri" pitchFamily="34" charset="-120"/>
+                <a:latin typeface="Fira Sans" pitchFamily="34" charset="0"/>
+                <a:ea typeface="Fira Sans" pitchFamily="34" charset="-122"/>
+                <a:cs typeface="Fira Sans" pitchFamily="34" charset="-120"/>
               </a:rPr>
               <a:t>WEITER MIT MODUL 10  →  Controlling &amp; Optimierung</a:t>
             </a:r>
@@ -5538,9 +5538,9 @@
                 <a:solidFill>
                   <a:srgbClr val="FFFFFF"/>
                 </a:solidFill>
-                <a:latin typeface="Calibri" pitchFamily="34" charset="0"/>
-                <a:ea typeface="Calibri" pitchFamily="34" charset="-122"/>
-                <a:cs typeface="Calibri" pitchFamily="34" charset="-120"/>
+                <a:latin typeface="Fira Sans" pitchFamily="34" charset="0"/>
+                <a:ea typeface="Fira Sans" pitchFamily="34" charset="-122"/>
+                <a:cs typeface="Fira Sans" pitchFamily="34" charset="-120"/>
               </a:rPr>
               <a:t>▶ 0:24</a:t>
             </a:r>
@@ -5577,9 +5577,9 @@
                 <a:solidFill>
                   <a:srgbClr val="6B7280"/>
                 </a:solidFill>
-                <a:latin typeface="Calibri" pitchFamily="34" charset="0"/>
-                <a:ea typeface="Calibri" pitchFamily="34" charset="-122"/>
-                <a:cs typeface="Calibri" pitchFamily="34" charset="-120"/>
+                <a:latin typeface="Fira Sans" pitchFamily="34" charset="0"/>
+                <a:ea typeface="Fira Sans" pitchFamily="34" charset="-122"/>
+                <a:cs typeface="Fira Sans" pitchFamily="34" charset="-120"/>
               </a:rPr>
               <a:t>ELEVATOR42  –  SMARTER WAYS TO LEARN</a:t>
             </a:r>
@@ -5717,13 +5717,13 @@
               <a:buNone/>
             </a:pPr>
             <a:r>
-              <a:rPr lang="en-US" sz="3000" b="1" dirty="0">
+              <a:rPr lang="en-US" sz="3000" dirty="0">
                 <a:solidFill>
                   <a:srgbClr val="FFFFFF"/>
                 </a:solidFill>
-                <a:latin typeface="Georgia" pitchFamily="34" charset="0"/>
-                <a:ea typeface="Georgia" pitchFamily="34" charset="-122"/>
-                <a:cs typeface="Georgia" pitchFamily="34" charset="-120"/>
+                <a:latin typeface="Fira Sans ExtraBold" pitchFamily="34" charset="0"/>
+                <a:ea typeface="Fira Sans ExtraBold" pitchFamily="34" charset="-122"/>
+                <a:cs typeface="Fira Sans ExtraBold" pitchFamily="34" charset="-120"/>
               </a:rPr>
               <a:t>Mehr</a:t>
             </a:r>
@@ -5737,13 +5737,13 @@
               <a:buNone/>
             </a:pPr>
             <a:r>
-              <a:rPr lang="en-US" sz="3000" b="1" dirty="0">
+              <a:rPr lang="en-US" sz="3000" dirty="0">
                 <a:solidFill>
                   <a:srgbClr val="FFFFFF"/>
                 </a:solidFill>
-                <a:latin typeface="Georgia" pitchFamily="34" charset="0"/>
-                <a:ea typeface="Georgia" pitchFamily="34" charset="-122"/>
-                <a:cs typeface="Georgia" pitchFamily="34" charset="-120"/>
+                <a:latin typeface="Fira Sans ExtraBold" pitchFamily="34" charset="0"/>
+                <a:ea typeface="Fira Sans ExtraBold" pitchFamily="34" charset="-122"/>
+                <a:cs typeface="Fira Sans ExtraBold" pitchFamily="34" charset="-120"/>
               </a:rPr>
               <a:t>Privatpatienten</a:t>
             </a:r>
@@ -5757,13 +5757,13 @@
               <a:buNone/>
             </a:pPr>
             <a:r>
-              <a:rPr lang="en-US" sz="3000" b="1" dirty="0">
+              <a:rPr lang="en-US" sz="3000" dirty="0">
                 <a:solidFill>
                   <a:srgbClr val="FFFFFF"/>
                 </a:solidFill>
-                <a:latin typeface="Georgia" pitchFamily="34" charset="0"/>
-                <a:ea typeface="Georgia" pitchFamily="34" charset="-122"/>
-                <a:cs typeface="Georgia" pitchFamily="34" charset="-120"/>
+                <a:latin typeface="Fira Sans ExtraBold" pitchFamily="34" charset="0"/>
+                <a:ea typeface="Fira Sans ExtraBold" pitchFamily="34" charset="-122"/>
+                <a:cs typeface="Fira Sans ExtraBold" pitchFamily="34" charset="-120"/>
               </a:rPr>
               <a:t>&amp; Selbstzahler</a:t>
             </a:r>
@@ -5777,13 +5777,13 @@
               <a:buNone/>
             </a:pPr>
             <a:r>
-              <a:rPr lang="en-US" sz="3000" b="1" dirty="0">
+              <a:rPr lang="en-US" sz="3000" dirty="0">
                 <a:solidFill>
                   <a:srgbClr val="FFFFFF"/>
                 </a:solidFill>
-                <a:latin typeface="Georgia" pitchFamily="34" charset="0"/>
-                <a:ea typeface="Georgia" pitchFamily="34" charset="-122"/>
-                <a:cs typeface="Georgia" pitchFamily="34" charset="-120"/>
+                <a:latin typeface="Fira Sans ExtraBold" pitchFamily="34" charset="0"/>
+                <a:ea typeface="Fira Sans ExtraBold" pitchFamily="34" charset="-122"/>
+                <a:cs typeface="Fira Sans ExtraBold" pitchFamily="34" charset="-120"/>
               </a:rPr>
               <a:t>gewinnen</a:t>
             </a:r>
@@ -5820,9 +5820,9 @@
                 <a:solidFill>
                   <a:srgbClr val="D6DCE5"/>
                 </a:solidFill>
-                <a:latin typeface="Calibri" pitchFamily="34" charset="0"/>
-                <a:ea typeface="Calibri" pitchFamily="34" charset="-122"/>
-                <a:cs typeface="Calibri" pitchFamily="34" charset="-120"/>
+                <a:latin typeface="Fira Sans" pitchFamily="34" charset="0"/>
+                <a:ea typeface="Fira Sans" pitchFamily="34" charset="-122"/>
+                <a:cs typeface="Fira Sans" pitchFamily="34" charset="-120"/>
               </a:rPr>
               <a:t>Die wirtschaftliche</a:t>
             </a:r>
@@ -5837,9 +5837,9 @@
                 <a:solidFill>
                   <a:srgbClr val="D6DCE5"/>
                 </a:solidFill>
-                <a:latin typeface="Calibri" pitchFamily="34" charset="0"/>
-                <a:ea typeface="Calibri" pitchFamily="34" charset="-122"/>
-                <a:cs typeface="Calibri" pitchFamily="34" charset="-120"/>
+                <a:latin typeface="Fira Sans" pitchFamily="34" charset="0"/>
+                <a:ea typeface="Fira Sans" pitchFamily="34" charset="-122"/>
+                <a:cs typeface="Fira Sans" pitchFamily="34" charset="-120"/>
               </a:rPr>
               <a:t>Wachstumsstrategie fuer</a:t>
             </a:r>
@@ -5854,9 +5854,9 @@
                 <a:solidFill>
                   <a:srgbClr val="D6DCE5"/>
                 </a:solidFill>
-                <a:latin typeface="Calibri" pitchFamily="34" charset="0"/>
-                <a:ea typeface="Calibri" pitchFamily="34" charset="-122"/>
-                <a:cs typeface="Calibri" pitchFamily="34" charset="-120"/>
+                <a:latin typeface="Fira Sans" pitchFamily="34" charset="0"/>
+                <a:ea typeface="Fira Sans" pitchFamily="34" charset="-122"/>
+                <a:cs typeface="Fira Sans" pitchFamily="34" charset="-120"/>
               </a:rPr>
               <a:t>moderne Praxen</a:t>
             </a:r>
@@ -5959,9 +5959,9 @@
                 <a:solidFill>
                   <a:srgbClr val="FFFFFF"/>
                 </a:solidFill>
-                <a:latin typeface="Calibri" pitchFamily="34" charset="0"/>
-                <a:ea typeface="Calibri" pitchFamily="34" charset="-122"/>
-                <a:cs typeface="Calibri" pitchFamily="34" charset="-120"/>
+                <a:latin typeface="Fira Sans" pitchFamily="34" charset="0"/>
+                <a:ea typeface="Fira Sans" pitchFamily="34" charset="-122"/>
+                <a:cs typeface="Fira Sans" pitchFamily="34" charset="-120"/>
               </a:rPr>
               <a:t>▶ 0:24</a:t>
             </a:r>

</xml_diff>

<commit_message>
Fix: Klara-Thumbnail deckt keinen Inhalt mehr ab, doppelter Aufruf entfernt
Co-Authored-By: Claude Sonnet 4.6 <noreply@anthropic.com>
</commit_message>
<xml_diff>
--- a/praesentationen-pptx/Elevator42_Modul9_Slides.pptx
+++ b/praesentationen-pptx/Elevator42_Modul9_Slides.pptx
@@ -1662,8 +1662,8 @@
         </p:nvSpPr>
         <p:spPr>
           <a:xfrm>
-            <a:off x="7269480" y="3520440"/>
-            <a:ext cx="1737360" cy="1417320"/>
+            <a:off x="7269480" y="4114800"/>
+            <a:ext cx="1737360" cy="914400"/>
           </a:xfrm>
           <a:prstGeom prst="rect">
             <a:avLst/>
@@ -1692,8 +1692,8 @@
         </p:blipFill>
         <p:spPr>
           <a:xfrm>
-            <a:off x="7315200" y="3566160"/>
-            <a:ext cx="1645920" cy="1188720"/>
+            <a:off x="7315200" y="4160520"/>
+            <a:ext cx="1645920" cy="704088"/>
           </a:xfrm>
           <a:prstGeom prst="rect">
             <a:avLst/>
@@ -1708,8 +1708,8 @@
         </p:nvSpPr>
         <p:spPr>
           <a:xfrm>
-            <a:off x="7315200" y="4590288"/>
-            <a:ext cx="1645920" cy="164592"/>
+            <a:off x="7315200" y="4882896"/>
+            <a:ext cx="1645920" cy="146304"/>
           </a:xfrm>
           <a:prstGeom prst="rect">
             <a:avLst/>
@@ -1728,24 +1728,24 @@
         </p:nvSpPr>
         <p:spPr>
           <a:xfrm>
-            <a:off x="7360920" y="4590288"/>
-            <a:ext cx="731520" cy="164592"/>
-          </a:xfrm>
-          <a:prstGeom prst="rect">
-            <a:avLst/>
-          </a:prstGeom>
-          <a:noFill/>
-          <a:ln/>
-        </p:spPr>
-        <p:txBody>
-          <a:bodyPr wrap="square" lIns="0" tIns="0" rIns="0" bIns="0" rtlCol="0" anchor="ctr"/>
-          <a:lstStyle/>
-          <a:p>
-            <a:pPr indent="0" marL="0">
-              <a:buNone/>
-            </a:pPr>
-            <a:r>
-              <a:rPr lang="en-US" sz="650" dirty="0">
+            <a:off x="7360920" y="4882896"/>
+            <a:ext cx="731520" cy="146304"/>
+          </a:xfrm>
+          <a:prstGeom prst="rect">
+            <a:avLst/>
+          </a:prstGeom>
+          <a:noFill/>
+          <a:ln/>
+        </p:spPr>
+        <p:txBody>
+          <a:bodyPr wrap="square" lIns="0" tIns="0" rIns="0" bIns="0" rtlCol="0" anchor="ctr"/>
+          <a:lstStyle/>
+          <a:p>
+            <a:pPr indent="0" marL="0">
+              <a:buNone/>
+            </a:pPr>
+            <a:r>
+              <a:rPr lang="en-US" sz="600" dirty="0">
                 <a:solidFill>
                   <a:srgbClr val="FFFFFF"/>
                 </a:solidFill>
@@ -1755,7 +1755,7 @@
               </a:rPr>
               <a:t>▶ 0:24</a:t>
             </a:r>
-            <a:endParaRPr lang="en-US" sz="650" dirty="0"/>
+            <a:endParaRPr lang="en-US" sz="600" dirty="0"/>
           </a:p>
         </p:txBody>
       </p:sp>
@@ -2369,8 +2369,8 @@
         </p:nvSpPr>
         <p:spPr>
           <a:xfrm>
-            <a:off x="7269480" y="3520440"/>
-            <a:ext cx="1737360" cy="1417320"/>
+            <a:off x="7269480" y="4114800"/>
+            <a:ext cx="1737360" cy="914400"/>
           </a:xfrm>
           <a:prstGeom prst="rect">
             <a:avLst/>
@@ -2399,8 +2399,8 @@
         </p:blipFill>
         <p:spPr>
           <a:xfrm>
-            <a:off x="7315200" y="3566160"/>
-            <a:ext cx="1645920" cy="1188720"/>
+            <a:off x="7315200" y="4160520"/>
+            <a:ext cx="1645920" cy="704088"/>
           </a:xfrm>
           <a:prstGeom prst="rect">
             <a:avLst/>
@@ -2415,8 +2415,8 @@
         </p:nvSpPr>
         <p:spPr>
           <a:xfrm>
-            <a:off x="7315200" y="4590288"/>
-            <a:ext cx="1645920" cy="164592"/>
+            <a:off x="7315200" y="4882896"/>
+            <a:ext cx="1645920" cy="146304"/>
           </a:xfrm>
           <a:prstGeom prst="rect">
             <a:avLst/>
@@ -2435,24 +2435,24 @@
         </p:nvSpPr>
         <p:spPr>
           <a:xfrm>
-            <a:off x="7360920" y="4590288"/>
-            <a:ext cx="731520" cy="164592"/>
-          </a:xfrm>
-          <a:prstGeom prst="rect">
-            <a:avLst/>
-          </a:prstGeom>
-          <a:noFill/>
-          <a:ln/>
-        </p:spPr>
-        <p:txBody>
-          <a:bodyPr wrap="square" lIns="0" tIns="0" rIns="0" bIns="0" rtlCol="0" anchor="ctr"/>
-          <a:lstStyle/>
-          <a:p>
-            <a:pPr indent="0" marL="0">
-              <a:buNone/>
-            </a:pPr>
-            <a:r>
-              <a:rPr lang="en-US" sz="650" dirty="0">
+            <a:off x="7360920" y="4882896"/>
+            <a:ext cx="731520" cy="146304"/>
+          </a:xfrm>
+          <a:prstGeom prst="rect">
+            <a:avLst/>
+          </a:prstGeom>
+          <a:noFill/>
+          <a:ln/>
+        </p:spPr>
+        <p:txBody>
+          <a:bodyPr wrap="square" lIns="0" tIns="0" rIns="0" bIns="0" rtlCol="0" anchor="ctr"/>
+          <a:lstStyle/>
+          <a:p>
+            <a:pPr indent="0" marL="0">
+              <a:buNone/>
+            </a:pPr>
+            <a:r>
+              <a:rPr lang="en-US" sz="600" dirty="0">
                 <a:solidFill>
                   <a:srgbClr val="FFFFFF"/>
                 </a:solidFill>
@@ -2462,118 +2462,13 @@
               </a:rPr>
               <a:t>▶ 0:24</a:t>
             </a:r>
-            <a:endParaRPr lang="en-US" sz="650" dirty="0"/>
-          </a:p>
-        </p:txBody>
-      </p:sp>
-      <p:sp>
-        <p:nvSpPr>
-          <p:cNvPr id="22" name="Shape 18"/>
-          <p:cNvSpPr/>
-          <p:nvPr/>
-        </p:nvSpPr>
-        <p:spPr>
-          <a:xfrm>
-            <a:off x="7269480" y="3520440"/>
-            <a:ext cx="1737360" cy="1417320"/>
-          </a:xfrm>
-          <a:prstGeom prst="rect">
-            <a:avLst/>
-          </a:prstGeom>
-          <a:solidFill>
-            <a:srgbClr val="FFFFFF">
-              <a:alpha val="85000"/>
-            </a:srgbClr>
-          </a:solidFill>
-          <a:ln/>
-        </p:spPr>
-      </p:sp>
-      <p:pic>
-        <p:nvPicPr>
-          <p:cNvPr id="23" name="Image 2" descr="preencoded.png">    </p:cNvPr>
-          <p:cNvPicPr>
-            <a:picLocks noChangeAspect="1"/>
-          </p:cNvPicPr>
-          <p:nvPr/>
-        </p:nvPicPr>
-        <p:blipFill>
-          <a:blip r:embed="rId3"/>
-          <a:stretch>
-            <a:fillRect/>
-          </a:stretch>
-        </p:blipFill>
-        <p:spPr>
-          <a:xfrm>
-            <a:off x="7315200" y="3566160"/>
-            <a:ext cx="1645920" cy="1188720"/>
-          </a:xfrm>
-          <a:prstGeom prst="rect">
-            <a:avLst/>
-          </a:prstGeom>
-        </p:spPr>
-      </p:pic>
-      <p:sp>
-        <p:nvSpPr>
-          <p:cNvPr id="24" name="Shape 19"/>
-          <p:cNvSpPr/>
-          <p:nvPr/>
-        </p:nvSpPr>
-        <p:spPr>
-          <a:xfrm>
-            <a:off x="7315200" y="4590288"/>
-            <a:ext cx="1645920" cy="164592"/>
-          </a:xfrm>
-          <a:prstGeom prst="rect">
-            <a:avLst/>
-          </a:prstGeom>
-          <a:solidFill>
-            <a:srgbClr val="333333"/>
-          </a:solidFill>
-          <a:ln/>
-        </p:spPr>
-      </p:sp>
-      <p:sp>
-        <p:nvSpPr>
-          <p:cNvPr id="25" name="Text 20"/>
-          <p:cNvSpPr/>
-          <p:nvPr/>
-        </p:nvSpPr>
-        <p:spPr>
-          <a:xfrm>
-            <a:off x="7360920" y="4590288"/>
-            <a:ext cx="731520" cy="164592"/>
-          </a:xfrm>
-          <a:prstGeom prst="rect">
-            <a:avLst/>
-          </a:prstGeom>
-          <a:noFill/>
-          <a:ln/>
-        </p:spPr>
-        <p:txBody>
-          <a:bodyPr wrap="square" lIns="0" tIns="0" rIns="0" bIns="0" rtlCol="0" anchor="ctr"/>
-          <a:lstStyle/>
-          <a:p>
-            <a:pPr indent="0" marL="0">
-              <a:buNone/>
-            </a:pPr>
-            <a:r>
-              <a:rPr lang="en-US" sz="650" dirty="0">
-                <a:solidFill>
-                  <a:srgbClr val="FFFFFF"/>
-                </a:solidFill>
-                <a:latin typeface="Fira Sans" pitchFamily="34" charset="0"/>
-                <a:ea typeface="Fira Sans" pitchFamily="34" charset="-122"/>
-                <a:cs typeface="Fira Sans" pitchFamily="34" charset="-120"/>
-              </a:rPr>
-              <a:t>▶ 0:24</a:t>
-            </a:r>
-            <a:endParaRPr lang="en-US" sz="650" dirty="0"/>
-          </a:p>
-        </p:txBody>
-      </p:sp>
-      <p:sp>
-        <p:nvSpPr>
-          <p:cNvPr id="26" name="Text 21"/>
+            <a:endParaRPr lang="en-US" sz="600" dirty="0"/>
+          </a:p>
+        </p:txBody>
+      </p:sp>
+      <p:sp>
+        <p:nvSpPr>
+          <p:cNvPr id="22" name="Text 18"/>
           <p:cNvSpPr/>
           <p:nvPr/>
         </p:nvSpPr>
@@ -3374,8 +3269,8 @@
         </p:nvSpPr>
         <p:spPr>
           <a:xfrm>
-            <a:off x="7269480" y="3520440"/>
-            <a:ext cx="1737360" cy="1417320"/>
+            <a:off x="7269480" y="4114800"/>
+            <a:ext cx="1737360" cy="914400"/>
           </a:xfrm>
           <a:prstGeom prst="rect">
             <a:avLst/>
@@ -3404,8 +3299,8 @@
         </p:blipFill>
         <p:spPr>
           <a:xfrm>
-            <a:off x="7315200" y="3566160"/>
-            <a:ext cx="1645920" cy="1188720"/>
+            <a:off x="7315200" y="4160520"/>
+            <a:ext cx="1645920" cy="704088"/>
           </a:xfrm>
           <a:prstGeom prst="rect">
             <a:avLst/>
@@ -3420,8 +3315,8 @@
         </p:nvSpPr>
         <p:spPr>
           <a:xfrm>
-            <a:off x="7315200" y="4590288"/>
-            <a:ext cx="1645920" cy="164592"/>
+            <a:off x="7315200" y="4882896"/>
+            <a:ext cx="1645920" cy="146304"/>
           </a:xfrm>
           <a:prstGeom prst="rect">
             <a:avLst/>
@@ -3440,24 +3335,24 @@
         </p:nvSpPr>
         <p:spPr>
           <a:xfrm>
-            <a:off x="7360920" y="4590288"/>
-            <a:ext cx="731520" cy="164592"/>
-          </a:xfrm>
-          <a:prstGeom prst="rect">
-            <a:avLst/>
-          </a:prstGeom>
-          <a:noFill/>
-          <a:ln/>
-        </p:spPr>
-        <p:txBody>
-          <a:bodyPr wrap="square" lIns="0" tIns="0" rIns="0" bIns="0" rtlCol="0" anchor="ctr"/>
-          <a:lstStyle/>
-          <a:p>
-            <a:pPr indent="0" marL="0">
-              <a:buNone/>
-            </a:pPr>
-            <a:r>
-              <a:rPr lang="en-US" sz="650" dirty="0">
+            <a:off x="7360920" y="4882896"/>
+            <a:ext cx="731520" cy="146304"/>
+          </a:xfrm>
+          <a:prstGeom prst="rect">
+            <a:avLst/>
+          </a:prstGeom>
+          <a:noFill/>
+          <a:ln/>
+        </p:spPr>
+        <p:txBody>
+          <a:bodyPr wrap="square" lIns="0" tIns="0" rIns="0" bIns="0" rtlCol="0" anchor="ctr"/>
+          <a:lstStyle/>
+          <a:p>
+            <a:pPr indent="0" marL="0">
+              <a:buNone/>
+            </a:pPr>
+            <a:r>
+              <a:rPr lang="en-US" sz="600" dirty="0">
                 <a:solidFill>
                   <a:srgbClr val="FFFFFF"/>
                 </a:solidFill>
@@ -3467,7 +3362,7 @@
               </a:rPr>
               <a:t>▶ 0:24</a:t>
             </a:r>
-            <a:endParaRPr lang="en-US" sz="650" dirty="0"/>
+            <a:endParaRPr lang="en-US" sz="600" dirty="0"/>
           </a:p>
         </p:txBody>
       </p:sp>
@@ -4328,8 +4223,8 @@
         </p:nvSpPr>
         <p:spPr>
           <a:xfrm>
-            <a:off x="7269480" y="3520440"/>
-            <a:ext cx="1737360" cy="1417320"/>
+            <a:off x="7269480" y="4114800"/>
+            <a:ext cx="1737360" cy="914400"/>
           </a:xfrm>
           <a:prstGeom prst="rect">
             <a:avLst/>
@@ -4358,8 +4253,8 @@
         </p:blipFill>
         <p:spPr>
           <a:xfrm>
-            <a:off x="7315200" y="3566160"/>
-            <a:ext cx="1645920" cy="1188720"/>
+            <a:off x="7315200" y="4160520"/>
+            <a:ext cx="1645920" cy="704088"/>
           </a:xfrm>
           <a:prstGeom prst="rect">
             <a:avLst/>
@@ -4374,8 +4269,8 @@
         </p:nvSpPr>
         <p:spPr>
           <a:xfrm>
-            <a:off x="7315200" y="4590288"/>
-            <a:ext cx="1645920" cy="164592"/>
+            <a:off x="7315200" y="4882896"/>
+            <a:ext cx="1645920" cy="146304"/>
           </a:xfrm>
           <a:prstGeom prst="rect">
             <a:avLst/>
@@ -4394,24 +4289,24 @@
         </p:nvSpPr>
         <p:spPr>
           <a:xfrm>
-            <a:off x="7360920" y="4590288"/>
-            <a:ext cx="731520" cy="164592"/>
-          </a:xfrm>
-          <a:prstGeom prst="rect">
-            <a:avLst/>
-          </a:prstGeom>
-          <a:noFill/>
-          <a:ln/>
-        </p:spPr>
-        <p:txBody>
-          <a:bodyPr wrap="square" lIns="0" tIns="0" rIns="0" bIns="0" rtlCol="0" anchor="ctr"/>
-          <a:lstStyle/>
-          <a:p>
-            <a:pPr indent="0" marL="0">
-              <a:buNone/>
-            </a:pPr>
-            <a:r>
-              <a:rPr lang="en-US" sz="650" dirty="0">
+            <a:off x="7360920" y="4882896"/>
+            <a:ext cx="731520" cy="146304"/>
+          </a:xfrm>
+          <a:prstGeom prst="rect">
+            <a:avLst/>
+          </a:prstGeom>
+          <a:noFill/>
+          <a:ln/>
+        </p:spPr>
+        <p:txBody>
+          <a:bodyPr wrap="square" lIns="0" tIns="0" rIns="0" bIns="0" rtlCol="0" anchor="ctr"/>
+          <a:lstStyle/>
+          <a:p>
+            <a:pPr indent="0" marL="0">
+              <a:buNone/>
+            </a:pPr>
+            <a:r>
+              <a:rPr lang="en-US" sz="600" dirty="0">
                 <a:solidFill>
                   <a:srgbClr val="FFFFFF"/>
                 </a:solidFill>
@@ -4421,7 +4316,7 @@
               </a:rPr>
               <a:t>▶ 0:24</a:t>
             </a:r>
-            <a:endParaRPr lang="en-US" sz="650" dirty="0"/>
+            <a:endParaRPr lang="en-US" sz="600" dirty="0"/>
           </a:p>
         </p:txBody>
       </p:sp>
@@ -5031,8 +4926,8 @@
         </p:nvSpPr>
         <p:spPr>
           <a:xfrm>
-            <a:off x="7269480" y="3520440"/>
-            <a:ext cx="1737360" cy="1417320"/>
+            <a:off x="7269480" y="4114800"/>
+            <a:ext cx="1737360" cy="914400"/>
           </a:xfrm>
           <a:prstGeom prst="rect">
             <a:avLst/>
@@ -5061,8 +4956,8 @@
         </p:blipFill>
         <p:spPr>
           <a:xfrm>
-            <a:off x="7315200" y="3566160"/>
-            <a:ext cx="1645920" cy="1188720"/>
+            <a:off x="7315200" y="4160520"/>
+            <a:ext cx="1645920" cy="704088"/>
           </a:xfrm>
           <a:prstGeom prst="rect">
             <a:avLst/>
@@ -5077,8 +4972,8 @@
         </p:nvSpPr>
         <p:spPr>
           <a:xfrm>
-            <a:off x="7315200" y="4590288"/>
-            <a:ext cx="1645920" cy="164592"/>
+            <a:off x="7315200" y="4882896"/>
+            <a:ext cx="1645920" cy="146304"/>
           </a:xfrm>
           <a:prstGeom prst="rect">
             <a:avLst/>
@@ -5097,24 +4992,24 @@
         </p:nvSpPr>
         <p:spPr>
           <a:xfrm>
-            <a:off x="7360920" y="4590288"/>
-            <a:ext cx="731520" cy="164592"/>
-          </a:xfrm>
-          <a:prstGeom prst="rect">
-            <a:avLst/>
-          </a:prstGeom>
-          <a:noFill/>
-          <a:ln/>
-        </p:spPr>
-        <p:txBody>
-          <a:bodyPr wrap="square" lIns="0" tIns="0" rIns="0" bIns="0" rtlCol="0" anchor="ctr"/>
-          <a:lstStyle/>
-          <a:p>
-            <a:pPr indent="0" marL="0">
-              <a:buNone/>
-            </a:pPr>
-            <a:r>
-              <a:rPr lang="en-US" sz="650" dirty="0">
+            <a:off x="7360920" y="4882896"/>
+            <a:ext cx="731520" cy="146304"/>
+          </a:xfrm>
+          <a:prstGeom prst="rect">
+            <a:avLst/>
+          </a:prstGeom>
+          <a:noFill/>
+          <a:ln/>
+        </p:spPr>
+        <p:txBody>
+          <a:bodyPr wrap="square" lIns="0" tIns="0" rIns="0" bIns="0" rtlCol="0" anchor="ctr"/>
+          <a:lstStyle/>
+          <a:p>
+            <a:pPr indent="0" marL="0">
+              <a:buNone/>
+            </a:pPr>
+            <a:r>
+              <a:rPr lang="en-US" sz="600" dirty="0">
                 <a:solidFill>
                   <a:srgbClr val="FFFFFF"/>
                 </a:solidFill>
@@ -5124,7 +5019,7 @@
               </a:rPr>
               <a:t>▶ 0:24</a:t>
             </a:r>
-            <a:endParaRPr lang="en-US" sz="650" dirty="0"/>
+            <a:endParaRPr lang="en-US" sz="600" dirty="0"/>
           </a:p>
         </p:txBody>
       </p:sp>
@@ -5451,8 +5346,8 @@
         </p:nvSpPr>
         <p:spPr>
           <a:xfrm>
-            <a:off x="7269480" y="3520440"/>
-            <a:ext cx="1737360" cy="1417320"/>
+            <a:off x="7269480" y="4114800"/>
+            <a:ext cx="1737360" cy="914400"/>
           </a:xfrm>
           <a:prstGeom prst="rect">
             <a:avLst/>
@@ -5481,8 +5376,8 @@
         </p:blipFill>
         <p:spPr>
           <a:xfrm>
-            <a:off x="7315200" y="3566160"/>
-            <a:ext cx="1645920" cy="1188720"/>
+            <a:off x="7315200" y="4160520"/>
+            <a:ext cx="1645920" cy="704088"/>
           </a:xfrm>
           <a:prstGeom prst="rect">
             <a:avLst/>
@@ -5497,8 +5392,8 @@
         </p:nvSpPr>
         <p:spPr>
           <a:xfrm>
-            <a:off x="7315200" y="4590288"/>
-            <a:ext cx="1645920" cy="164592"/>
+            <a:off x="7315200" y="4882896"/>
+            <a:ext cx="1645920" cy="146304"/>
           </a:xfrm>
           <a:prstGeom prst="rect">
             <a:avLst/>
@@ -5517,24 +5412,24 @@
         </p:nvSpPr>
         <p:spPr>
           <a:xfrm>
-            <a:off x="7360920" y="4590288"/>
-            <a:ext cx="731520" cy="164592"/>
-          </a:xfrm>
-          <a:prstGeom prst="rect">
-            <a:avLst/>
-          </a:prstGeom>
-          <a:noFill/>
-          <a:ln/>
-        </p:spPr>
-        <p:txBody>
-          <a:bodyPr wrap="square" lIns="0" tIns="0" rIns="0" bIns="0" rtlCol="0" anchor="ctr"/>
-          <a:lstStyle/>
-          <a:p>
-            <a:pPr indent="0" marL="0">
-              <a:buNone/>
-            </a:pPr>
-            <a:r>
-              <a:rPr lang="en-US" sz="650" dirty="0">
+            <a:off x="7360920" y="4882896"/>
+            <a:ext cx="731520" cy="146304"/>
+          </a:xfrm>
+          <a:prstGeom prst="rect">
+            <a:avLst/>
+          </a:prstGeom>
+          <a:noFill/>
+          <a:ln/>
+        </p:spPr>
+        <p:txBody>
+          <a:bodyPr wrap="square" lIns="0" tIns="0" rIns="0" bIns="0" rtlCol="0" anchor="ctr"/>
+          <a:lstStyle/>
+          <a:p>
+            <a:pPr indent="0" marL="0">
+              <a:buNone/>
+            </a:pPr>
+            <a:r>
+              <a:rPr lang="en-US" sz="600" dirty="0">
                 <a:solidFill>
                   <a:srgbClr val="FFFFFF"/>
                 </a:solidFill>
@@ -5544,7 +5439,7 @@
               </a:rPr>
               <a:t>▶ 0:24</a:t>
             </a:r>
-            <a:endParaRPr lang="en-US" sz="650" dirty="0"/>
+            <a:endParaRPr lang="en-US" sz="600" dirty="0"/>
           </a:p>
         </p:txBody>
       </p:sp>
@@ -5872,8 +5767,8 @@
         </p:nvSpPr>
         <p:spPr>
           <a:xfrm>
-            <a:off x="7269480" y="3520440"/>
-            <a:ext cx="1737360" cy="1417320"/>
+            <a:off x="7269480" y="4114800"/>
+            <a:ext cx="1737360" cy="914400"/>
           </a:xfrm>
           <a:prstGeom prst="rect">
             <a:avLst/>
@@ -5902,8 +5797,8 @@
         </p:blipFill>
         <p:spPr>
           <a:xfrm>
-            <a:off x="7315200" y="3566160"/>
-            <a:ext cx="1645920" cy="1188720"/>
+            <a:off x="7315200" y="4160520"/>
+            <a:ext cx="1645920" cy="704088"/>
           </a:xfrm>
           <a:prstGeom prst="rect">
             <a:avLst/>
@@ -5918,8 +5813,8 @@
         </p:nvSpPr>
         <p:spPr>
           <a:xfrm>
-            <a:off x="7315200" y="4590288"/>
-            <a:ext cx="1645920" cy="164592"/>
+            <a:off x="7315200" y="4882896"/>
+            <a:ext cx="1645920" cy="146304"/>
           </a:xfrm>
           <a:prstGeom prst="rect">
             <a:avLst/>
@@ -5938,24 +5833,24 @@
         </p:nvSpPr>
         <p:spPr>
           <a:xfrm>
-            <a:off x="7360920" y="4590288"/>
-            <a:ext cx="731520" cy="164592"/>
-          </a:xfrm>
-          <a:prstGeom prst="rect">
-            <a:avLst/>
-          </a:prstGeom>
-          <a:noFill/>
-          <a:ln/>
-        </p:spPr>
-        <p:txBody>
-          <a:bodyPr wrap="square" lIns="0" tIns="0" rIns="0" bIns="0" rtlCol="0" anchor="ctr"/>
-          <a:lstStyle/>
-          <a:p>
-            <a:pPr indent="0" marL="0">
-              <a:buNone/>
-            </a:pPr>
-            <a:r>
-              <a:rPr lang="en-US" sz="650" dirty="0">
+            <a:off x="7360920" y="4882896"/>
+            <a:ext cx="731520" cy="146304"/>
+          </a:xfrm>
+          <a:prstGeom prst="rect">
+            <a:avLst/>
+          </a:prstGeom>
+          <a:noFill/>
+          <a:ln/>
+        </p:spPr>
+        <p:txBody>
+          <a:bodyPr wrap="square" lIns="0" tIns="0" rIns="0" bIns="0" rtlCol="0" anchor="ctr"/>
+          <a:lstStyle/>
+          <a:p>
+            <a:pPr indent="0" marL="0">
+              <a:buNone/>
+            </a:pPr>
+            <a:r>
+              <a:rPr lang="en-US" sz="600" dirty="0">
                 <a:solidFill>
                   <a:srgbClr val="FFFFFF"/>
                 </a:solidFill>
@@ -5965,7 +5860,7 @@
               </a:rPr>
               <a:t>▶ 0:24</a:t>
             </a:r>
-            <a:endParaRPr lang="en-US" sz="650" dirty="0"/>
+            <a:endParaRPr lang="en-US" sz="600" dirty="0"/>
           </a:p>
         </p:txBody>
       </p:sp>

</xml_diff>